<commit_message>
Add PPT to start with the pitch for the Data Sorters  project. This is a presentation that was used to pitch the idea to StackUp.
</commit_message>
<xml_diff>
--- a/docs/Data Sorters Identity Guard - StackUp Pitch.pptx
+++ b/docs/Data Sorters Identity Guard - StackUp Pitch.pptx
@@ -25,16 +25,26 @@
       <p:boldItalic r:id="rId14"/>
     </p:embeddedFont>
     <p:embeddedFont>
+      <p:font typeface="Open Sans Semibold" panose="020B0706030804020204" pitchFamily="34" charset="0"/>
+      <p:bold r:id="rId15"/>
+      <p:boldItalic r:id="rId16"/>
+    </p:embeddedFont>
+    <p:embeddedFont>
+      <p:font typeface="Open Sans Semibold" panose="020B0706030804020204" pitchFamily="34" charset="0"/>
+      <p:bold r:id="rId15"/>
+      <p:boldItalic r:id="rId16"/>
+    </p:embeddedFont>
+    <p:embeddedFont>
       <p:font typeface="Roboto" panose="02000000000000000000" pitchFamily="2" charset="0"/>
-      <p:regular r:id="rId15"/>
-      <p:bold r:id="rId16"/>
-      <p:italic r:id="rId17"/>
-      <p:boldItalic r:id="rId18"/>
+      <p:regular r:id="rId17"/>
+      <p:bold r:id="rId18"/>
+      <p:italic r:id="rId19"/>
+      <p:boldItalic r:id="rId20"/>
     </p:embeddedFont>
     <p:embeddedFont>
       <p:font typeface="Sora" panose="020B0604020202020204" charset="0"/>
-      <p:regular r:id="rId19"/>
-      <p:bold r:id="rId20"/>
+      <p:regular r:id="rId21"/>
+      <p:bold r:id="rId22"/>
     </p:embeddedFont>
   </p:embeddedFontLst>
   <p:defaultTextStyle>
@@ -141,6 +151,121 @@
   <p188:author id="{2D3A8388-CBC0-534A-71EE-E9AE6F3F76F6}" name="Amit Gupta" initials="" userId="S::amit@keenstack.com::0bbe7fe7-71a7-4ff3-b29b-f0f6662eaeb9" providerId="AD"/>
   <p188:author id="{9CE165F1-1CA4-6877-EABB-4B6AD8F7E4E6}" name="Emma Dicker" initials="ED" userId="S::emma@keenstack.com::b5010ae8-8437-44d1-9ff4-f75f04ec520d" providerId="AD"/>
 </p188:authorLst>
+</file>
+
+<file path=ppt/revisionInfo.xml><?xml version="1.0" encoding="utf-8"?>
+<p1510:revInfo xmlns:a="http://schemas.openxmlformats.org/drawingml/2006/main" xmlns:r="http://schemas.openxmlformats.org/officeDocument/2006/relationships" xmlns:p1510="http://schemas.microsoft.com/office/powerpoint/2015/10/main">
+  <p1510:revLst>
+    <p1510:client id="{76C79448-2CA1-4E93-9EC5-B28F369409CA}" v="2" dt="2026-07-21T02:07:34.698"/>
+  </p1510:revLst>
+</p1510:revInfo>
+</file>
+
+<file path=ppt/changesInfos/changesInfo1.xml><?xml version="1.0" encoding="utf-8"?>
+<pc:chgInfo xmlns:a="http://schemas.openxmlformats.org/drawingml/2006/main" xmlns:r="http://schemas.openxmlformats.org/officeDocument/2006/relationships" xmlns:ac="http://schemas.microsoft.com/office/drawing/2013/main/command" xmlns:pc="http://schemas.microsoft.com/office/powerpoint/2013/main/command">
+  <pc:docChgLst>
+    <pc:chgData name="Cristobal Lizarraga" userId="f6ca2b2038fdcdd7" providerId="LiveId" clId="{5BB18A36-5346-42E4-8FA2-677660C9EE20}"/>
+    <pc:docChg chg="undo custSel modSld">
+      <pc:chgData name="Cristobal Lizarraga" userId="f6ca2b2038fdcdd7" providerId="LiveId" clId="{5BB18A36-5346-42E4-8FA2-677660C9EE20}" dt="2026-07-21T02:10:23.638" v="58" actId="1038"/>
+      <pc:docMkLst>
+        <pc:docMk/>
+      </pc:docMkLst>
+      <pc:sldChg chg="addSp delSp modSp mod">
+        <pc:chgData name="Cristobal Lizarraga" userId="f6ca2b2038fdcdd7" providerId="LiveId" clId="{5BB18A36-5346-42E4-8FA2-677660C9EE20}" dt="2026-07-21T02:08:20.012" v="33" actId="20577"/>
+        <pc:sldMkLst>
+          <pc:docMk/>
+          <pc:sldMk cId="3823065422" sldId="2147479171"/>
+        </pc:sldMkLst>
+        <pc:spChg chg="add mod">
+          <ac:chgData name="Cristobal Lizarraga" userId="f6ca2b2038fdcdd7" providerId="LiveId" clId="{5BB18A36-5346-42E4-8FA2-677660C9EE20}" dt="2026-07-21T02:08:20.012" v="33" actId="20577"/>
+          <ac:spMkLst>
+            <pc:docMk/>
+            <pc:sldMk cId="3823065422" sldId="2147479171"/>
+            <ac:spMk id="4" creationId="{1CF4EE2B-6E4B-EEC8-99DE-ECD13A47E378}"/>
+          </ac:spMkLst>
+        </pc:spChg>
+        <pc:spChg chg="del mod">
+          <ac:chgData name="Cristobal Lizarraga" userId="f6ca2b2038fdcdd7" providerId="LiveId" clId="{5BB18A36-5346-42E4-8FA2-677660C9EE20}" dt="2026-07-21T02:07:48.077" v="5" actId="478"/>
+          <ac:spMkLst>
+            <pc:docMk/>
+            <pc:sldMk cId="3823065422" sldId="2147479171"/>
+            <ac:spMk id="6" creationId="{C3C80FCD-87B7-D24A-A890-441A0D756C71}"/>
+          </ac:spMkLst>
+        </pc:spChg>
+        <pc:spChg chg="add del mod">
+          <ac:chgData name="Cristobal Lizarraga" userId="f6ca2b2038fdcdd7" providerId="LiveId" clId="{5BB18A36-5346-42E4-8FA2-677660C9EE20}" dt="2026-07-21T02:07:54.983" v="6" actId="478"/>
+          <ac:spMkLst>
+            <pc:docMk/>
+            <pc:sldMk cId="3823065422" sldId="2147479171"/>
+            <ac:spMk id="7" creationId="{FF230A49-BAF9-D187-617E-61F1DD040BE9}"/>
+          </ac:spMkLst>
+        </pc:spChg>
+        <pc:picChg chg="add del">
+          <ac:chgData name="Cristobal Lizarraga" userId="f6ca2b2038fdcdd7" providerId="LiveId" clId="{5BB18A36-5346-42E4-8FA2-677660C9EE20}" dt="2026-07-21T02:07:15.938" v="1" actId="22"/>
+          <ac:picMkLst>
+            <pc:docMk/>
+            <pc:sldMk cId="3823065422" sldId="2147479171"/>
+            <ac:picMk id="3" creationId="{890DD68C-ECC0-7583-EA13-578BCCBF98FA}"/>
+          </ac:picMkLst>
+        </pc:picChg>
+      </pc:sldChg>
+      <pc:sldChg chg="modSp mod">
+        <pc:chgData name="Cristobal Lizarraga" userId="f6ca2b2038fdcdd7" providerId="LiveId" clId="{5BB18A36-5346-42E4-8FA2-677660C9EE20}" dt="2026-07-21T02:09:40.013" v="57" actId="20577"/>
+        <pc:sldMkLst>
+          <pc:docMk/>
+          <pc:sldMk cId="1579664940" sldId="2147483558"/>
+        </pc:sldMkLst>
+        <pc:spChg chg="mod">
+          <ac:chgData name="Cristobal Lizarraga" userId="f6ca2b2038fdcdd7" providerId="LiveId" clId="{5BB18A36-5346-42E4-8FA2-677660C9EE20}" dt="2026-07-21T02:09:40.013" v="57" actId="20577"/>
+          <ac:spMkLst>
+            <pc:docMk/>
+            <pc:sldMk cId="1579664940" sldId="2147483558"/>
+            <ac:spMk id="23" creationId="{00000000-0000-0000-0000-000000000000}"/>
+          </ac:spMkLst>
+        </pc:spChg>
+      </pc:sldChg>
+      <pc:sldChg chg="modSp mod">
+        <pc:chgData name="Cristobal Lizarraga" userId="f6ca2b2038fdcdd7" providerId="LiveId" clId="{5BB18A36-5346-42E4-8FA2-677660C9EE20}" dt="2026-07-21T02:10:23.638" v="58" actId="1038"/>
+        <pc:sldMkLst>
+          <pc:docMk/>
+          <pc:sldMk cId="1287334656" sldId="2147483578"/>
+        </pc:sldMkLst>
+        <pc:spChg chg="mod">
+          <ac:chgData name="Cristobal Lizarraga" userId="f6ca2b2038fdcdd7" providerId="LiveId" clId="{5BB18A36-5346-42E4-8FA2-677660C9EE20}" dt="2026-07-21T02:09:06.598" v="56" actId="1038"/>
+          <ac:spMkLst>
+            <pc:docMk/>
+            <pc:sldMk cId="1287334656" sldId="2147483578"/>
+            <ac:spMk id="16" creationId="{00000000-0000-0000-0000-000000000000}"/>
+          </ac:spMkLst>
+        </pc:spChg>
+        <pc:spChg chg="mod">
+          <ac:chgData name="Cristobal Lizarraga" userId="f6ca2b2038fdcdd7" providerId="LiveId" clId="{5BB18A36-5346-42E4-8FA2-677660C9EE20}" dt="2026-07-21T02:08:43.008" v="44" actId="1037"/>
+          <ac:spMkLst>
+            <pc:docMk/>
+            <pc:sldMk cId="1287334656" sldId="2147483578"/>
+            <ac:spMk id="21" creationId="{00000000-0000-0000-0000-000000000000}"/>
+          </ac:spMkLst>
+        </pc:spChg>
+        <pc:spChg chg="mod">
+          <ac:chgData name="Cristobal Lizarraga" userId="f6ca2b2038fdcdd7" providerId="LiveId" clId="{5BB18A36-5346-42E4-8FA2-677660C9EE20}" dt="2026-07-21T02:10:23.638" v="58" actId="1038"/>
+          <ac:spMkLst>
+            <pc:docMk/>
+            <pc:sldMk cId="1287334656" sldId="2147483578"/>
+            <ac:spMk id="26" creationId="{00000000-0000-0000-0000-000000000000}"/>
+          </ac:spMkLst>
+        </pc:spChg>
+        <pc:spChg chg="mod">
+          <ac:chgData name="Cristobal Lizarraga" userId="f6ca2b2038fdcdd7" providerId="LiveId" clId="{5BB18A36-5346-42E4-8FA2-677660C9EE20}" dt="2026-07-21T02:09:02.333" v="55" actId="1037"/>
+          <ac:spMkLst>
+            <pc:docMk/>
+            <pc:sldMk cId="1287334656" sldId="2147483578"/>
+            <ac:spMk id="31" creationId="{00000000-0000-0000-0000-000000000000}"/>
+          </ac:spMkLst>
+        </pc:spChg>
+      </pc:sldChg>
+    </pc:docChg>
+  </pc:docChgLst>
+</pc:chgInfo>
 </file>
 
 <file path=ppt/notesMasters/notesMaster1.xml><?xml version="1.0" encoding="utf-8"?>
@@ -20099,53 +20224,6 @@
           <a:chExt cx="0" cy="0"/>
         </a:xfrm>
       </p:grpSpPr>
-      <p:sp>
-        <p:nvSpPr>
-          <p:cNvPr id="6" name="Title 5">
-            <a:extLst>
-              <a:ext uri="{FF2B5EF4-FFF2-40B4-BE49-F238E27FC236}">
-                <a16:creationId xmlns:a16="http://schemas.microsoft.com/office/drawing/2014/main" id="{C3C80FCD-87B7-D24A-A890-441A0D756C71}"/>
-              </a:ext>
-            </a:extLst>
-          </p:cNvPr>
-          <p:cNvSpPr>
-            <a:spLocks noGrp="1"/>
-          </p:cNvSpPr>
-          <p:nvPr>
-            <p:ph type="ctrTitle"/>
-          </p:nvPr>
-        </p:nvSpPr>
-        <p:spPr>
-          <a:xfrm>
-            <a:off x="716874" y="2148396"/>
-            <a:ext cx="5124704" cy="1998176"/>
-          </a:xfrm>
-        </p:spPr>
-        <p:txBody>
-          <a:bodyPr wrap="square" anchor="t">
-            <a:spAutoFit/>
-          </a:bodyPr>
-          <a:lstStyle/>
-          <a:p>
-            <a:pPr>
-              <a:defRPr sz="3400" b="1">
-                <a:solidFill>
-                  <a:srgbClr val="091F38"/>
-                </a:solidFill>
-                <a:latin typeface="Aptos"/>
-              </a:defRPr>
-            </a:pPr>
-            <a:r>
-              <a:t>StackUp 2026</a:t>
-            </a:r>
-            <a:br/>
-            <a:br/>
-            <a:r>
-              <a:t>Team - Data Sorters</a:t>
-            </a:r>
-          </a:p>
-        </p:txBody>
-      </p:sp>
       <p:pic>
         <p:nvPicPr>
           <p:cNvPr id="10" name="Picture 9" descr="A person and person in a blue and white diamond shaped box  Description automatically generated">
@@ -20231,6 +20309,100 @@
           <a:p>
             <a:pPr algn="ctr"/>
             <a:endParaRPr lang="en-US"/>
+          </a:p>
+        </p:txBody>
+      </p:sp>
+      <p:sp>
+        <p:nvSpPr>
+          <p:cNvPr id="4" name="Title 5">
+            <a:extLst>
+              <a:ext uri="{FF2B5EF4-FFF2-40B4-BE49-F238E27FC236}">
+                <a16:creationId xmlns:a16="http://schemas.microsoft.com/office/drawing/2014/main" id="{1CF4EE2B-6E4B-EEC8-99DE-ECD13A47E378}"/>
+              </a:ext>
+            </a:extLst>
+          </p:cNvPr>
+          <p:cNvSpPr txBox="1">
+            <a:spLocks/>
+          </p:cNvSpPr>
+          <p:nvPr/>
+        </p:nvSpPr>
+        <p:spPr>
+          <a:xfrm>
+            <a:off x="689980" y="2130918"/>
+            <a:ext cx="5124704" cy="1998176"/>
+          </a:xfrm>
+          <a:prstGeom prst="rect">
+            <a:avLst/>
+          </a:prstGeom>
+        </p:spPr>
+        <p:txBody>
+          <a:bodyPr vert="horz" wrap="square" lIns="0" tIns="0" rIns="0" bIns="0" rtlCol="0" anchor="t" anchorCtr="0">
+            <a:spAutoFit/>
+          </a:bodyPr>
+          <a:lstStyle>
+            <a:lvl1pPr algn="l" defTabSz="914400" rtl="0" eaLnBrk="1" latinLnBrk="0" hangingPunct="1">
+              <a:lnSpc>
+                <a:spcPct val="90000"/>
+              </a:lnSpc>
+              <a:spcBef>
+                <a:spcPct val="0"/>
+              </a:spcBef>
+              <a:buNone/>
+              <a:defRPr sz="5400" kern="1200">
+                <a:solidFill>
+                  <a:schemeClr val="bg2"/>
+                </a:solidFill>
+                <a:latin typeface="+mj-lt"/>
+                <a:ea typeface="+mj-ea"/>
+                <a:cs typeface="+mj-cs"/>
+              </a:defRPr>
+            </a:lvl1pPr>
+          </a:lstStyle>
+          <a:p>
+            <a:r>
+              <a:rPr lang="en-US" sz="4800" b="1" dirty="0" err="1">
+                <a:solidFill>
+                  <a:schemeClr val="accent3"/>
+                </a:solidFill>
+                <a:latin typeface="Sora"/>
+                <a:cs typeface="Sora"/>
+              </a:rPr>
+              <a:t>StackUp</a:t>
+            </a:r>
+            <a:r>
+              <a:rPr lang="en-US" sz="4800" b="1" dirty="0">
+                <a:solidFill>
+                  <a:schemeClr val="accent3"/>
+                </a:solidFill>
+                <a:latin typeface="Sora"/>
+                <a:cs typeface="Sora"/>
+              </a:rPr>
+              <a:t> 2026</a:t>
+            </a:r>
+            <a:br>
+              <a:rPr lang="en-US" sz="4800" b="1" dirty="0">
+                <a:solidFill>
+                  <a:schemeClr val="accent3"/>
+                </a:solidFill>
+                <a:latin typeface="Sora"/>
+                <a:cs typeface="Sora"/>
+              </a:rPr>
+            </a:br>
+            <a:br>
+              <a:rPr lang="en-US" sz="4800" b="1" dirty="0">
+                <a:solidFill>
+                  <a:schemeClr val="accent3"/>
+                </a:solidFill>
+                <a:latin typeface="Sora"/>
+                <a:cs typeface="Sora"/>
+              </a:rPr>
+            </a:br>
+            <a:r>
+              <a:rPr lang="en-US" sz="4800" b="1" dirty="0">
+                <a:cs typeface="Sora"/>
+              </a:rPr>
+              <a:t>Data Sorters</a:t>
+            </a:r>
           </a:p>
         </p:txBody>
       </p:sp>
@@ -20492,6 +20664,7 @@
             <a:pPr>
               <a:buNone/>
             </a:pPr>
+            <a:endParaRPr/>
           </a:p>
         </p:txBody>
       </p:sp>
@@ -20512,7 +20685,7 @@
           <a:noFill/>
         </p:spPr>
         <p:txBody>
-          <a:bodyPr wrap="square" lIns="45720" rIns="45720" tIns="27432" bIns="27432">
+          <a:bodyPr wrap="square" lIns="45720" tIns="27432" rIns="45720" bIns="27432">
             <a:spAutoFit/>
           </a:bodyPr>
           <a:lstStyle/>
@@ -20573,6 +20746,7 @@
           <a:lstStyle/>
           <a:p>
             <a:pPr algn="ctr"/>
+            <a:endParaRPr/>
           </a:p>
         </p:txBody>
       </p:sp>
@@ -20616,6 +20790,7 @@
           <a:lstStyle/>
           <a:p>
             <a:pPr algn="ctr"/>
+            <a:endParaRPr/>
           </a:p>
         </p:txBody>
       </p:sp>
@@ -20636,7 +20811,7 @@
           <a:noFill/>
         </p:spPr>
         <p:txBody>
-          <a:bodyPr wrap="square" lIns="45720" rIns="45720" tIns="27432" bIns="27432">
+          <a:bodyPr wrap="square" lIns="45720" tIns="27432" rIns="45720" bIns="27432">
             <a:spAutoFit/>
           </a:bodyPr>
           <a:lstStyle/>
@@ -20672,7 +20847,7 @@
           <a:noFill/>
         </p:spPr>
         <p:txBody>
-          <a:bodyPr wrap="square" lIns="45720" rIns="45720" tIns="27432" bIns="27432">
+          <a:bodyPr wrap="square" lIns="45720" tIns="27432" rIns="45720" bIns="27432">
             <a:spAutoFit/>
           </a:bodyPr>
           <a:lstStyle/>
@@ -20733,6 +20908,7 @@
           <a:lstStyle/>
           <a:p>
             <a:pPr algn="ctr"/>
+            <a:endParaRPr/>
           </a:p>
         </p:txBody>
       </p:sp>
@@ -20776,6 +20952,7 @@
           <a:lstStyle/>
           <a:p>
             <a:pPr algn="ctr"/>
+            <a:endParaRPr/>
           </a:p>
         </p:txBody>
       </p:sp>
@@ -20796,7 +20973,7 @@
           <a:noFill/>
         </p:spPr>
         <p:txBody>
-          <a:bodyPr wrap="square" lIns="45720" rIns="45720" tIns="27432" bIns="27432">
+          <a:bodyPr wrap="square" lIns="45720" tIns="27432" rIns="45720" bIns="27432">
             <a:spAutoFit/>
           </a:bodyPr>
           <a:lstStyle/>
@@ -20832,7 +21009,7 @@
           <a:noFill/>
         </p:spPr>
         <p:txBody>
-          <a:bodyPr wrap="square" lIns="45720" rIns="45720" tIns="27432" bIns="27432">
+          <a:bodyPr wrap="square" lIns="45720" tIns="27432" rIns="45720" bIns="27432">
             <a:spAutoFit/>
           </a:bodyPr>
           <a:lstStyle/>
@@ -20893,6 +21070,7 @@
           <a:lstStyle/>
           <a:p>
             <a:pPr algn="ctr"/>
+            <a:endParaRPr/>
           </a:p>
         </p:txBody>
       </p:sp>
@@ -20936,6 +21114,7 @@
           <a:lstStyle/>
           <a:p>
             <a:pPr algn="ctr"/>
+            <a:endParaRPr/>
           </a:p>
         </p:txBody>
       </p:sp>
@@ -20956,7 +21135,7 @@
           <a:noFill/>
         </p:spPr>
         <p:txBody>
-          <a:bodyPr wrap="square" lIns="45720" rIns="45720" tIns="27432" bIns="27432">
+          <a:bodyPr wrap="square" lIns="45720" tIns="27432" rIns="45720" bIns="27432">
             <a:spAutoFit/>
           </a:bodyPr>
           <a:lstStyle/>
@@ -20984,7 +21163,7 @@
         <p:spPr>
           <a:xfrm>
             <a:off x="7891271" y="1920240"/>
-            <a:ext cx="2633472" cy="1280160"/>
+            <a:ext cx="2633472" cy="701731"/>
           </a:xfrm>
           <a:prstGeom prst="rect">
             <a:avLst/>
@@ -20992,7 +21171,7 @@
           <a:noFill/>
         </p:spPr>
         <p:txBody>
-          <a:bodyPr wrap="square" lIns="45720" rIns="45720" tIns="27432" bIns="27432">
+          <a:bodyPr wrap="square" lIns="45720" tIns="27432" rIns="45720" bIns="27432">
             <a:spAutoFit/>
           </a:bodyPr>
           <a:lstStyle/>
@@ -21006,7 +21185,8 @@
               </a:defRPr>
             </a:pPr>
             <a:r>
-              <a:t>Now Assist Skill Kit writes grounded summaries, limitations, recommended actions, confidence, and IRE-style guardrail recommendations back into scoped records.</a:t>
+              <a:rPr dirty="0"/>
+              <a:t>Now Assist Skill Kit writes grounded summaries, limitations, recommended actions, confidence, and IRE-style guardrail recommendations back into records.</a:t>
             </a:r>
           </a:p>
         </p:txBody>
@@ -21053,6 +21233,7 @@
           <a:lstStyle/>
           <a:p>
             <a:pPr algn="ctr"/>
+            <a:endParaRPr/>
           </a:p>
         </p:txBody>
       </p:sp>
@@ -21073,7 +21254,7 @@
           <a:noFill/>
         </p:spPr>
         <p:txBody>
-          <a:bodyPr wrap="square" lIns="45720" rIns="45720" tIns="27432" bIns="27432">
+          <a:bodyPr wrap="square" lIns="45720" tIns="27432" rIns="45720" bIns="27432">
             <a:spAutoFit/>
           </a:bodyPr>
           <a:lstStyle/>
@@ -21109,7 +21290,7 @@
           <a:noFill/>
         </p:spPr>
         <p:txBody>
-          <a:bodyPr wrap="square" lIns="45720" rIns="45720" tIns="27432" bIns="27432">
+          <a:bodyPr wrap="square" lIns="45720" tIns="27432" rIns="45720" bIns="27432">
             <a:spAutoFit/>
           </a:bodyPr>
           <a:lstStyle/>
@@ -21145,7 +21326,7 @@
           <a:noFill/>
         </p:spPr>
         <p:txBody>
-          <a:bodyPr wrap="square" lIns="45720" rIns="45720" tIns="27432" bIns="27432">
+          <a:bodyPr wrap="square" lIns="45720" tIns="27432" rIns="45720" bIns="27432">
             <a:spAutoFit/>
           </a:bodyPr>
           <a:lstStyle/>
@@ -21181,7 +21362,7 @@
           <a:noFill/>
         </p:spPr>
         <p:txBody>
-          <a:bodyPr wrap="square" lIns="45720" rIns="45720" tIns="27432" bIns="27432">
+          <a:bodyPr wrap="square" lIns="45720" tIns="27432" rIns="45720" bIns="27432">
             <a:spAutoFit/>
           </a:bodyPr>
           <a:lstStyle/>
@@ -21458,6 +21639,7 @@
             <a:pPr>
               <a:buNone/>
             </a:pPr>
+            <a:endParaRPr/>
           </a:p>
         </p:txBody>
       </p:sp>
@@ -21478,7 +21660,7 @@
           <a:noFill/>
         </p:spPr>
         <p:txBody>
-          <a:bodyPr wrap="square" lIns="45720" rIns="45720" tIns="27432" bIns="27432">
+          <a:bodyPr wrap="square" lIns="45720" tIns="27432" rIns="45720" bIns="27432">
             <a:spAutoFit/>
           </a:bodyPr>
           <a:lstStyle/>
@@ -21539,6 +21721,7 @@
           <a:lstStyle/>
           <a:p>
             <a:pPr algn="ctr"/>
+            <a:endParaRPr/>
           </a:p>
         </p:txBody>
       </p:sp>
@@ -21582,6 +21765,7 @@
           <a:lstStyle/>
           <a:p>
             <a:pPr algn="ctr"/>
+            <a:endParaRPr/>
           </a:p>
         </p:txBody>
       </p:sp>
@@ -21602,7 +21786,7 @@
           <a:noFill/>
         </p:spPr>
         <p:txBody>
-          <a:bodyPr wrap="square" lIns="45720" rIns="45720" tIns="27432" bIns="27432">
+          <a:bodyPr wrap="square" lIns="45720" tIns="27432" rIns="45720" bIns="27432">
             <a:spAutoFit/>
           </a:bodyPr>
           <a:lstStyle/>
@@ -21638,7 +21822,7 @@
           <a:noFill/>
         </p:spPr>
         <p:txBody>
-          <a:bodyPr wrap="square" lIns="45720" rIns="45720" tIns="27432" bIns="27432">
+          <a:bodyPr wrap="square" lIns="45720" tIns="27432" rIns="45720" bIns="27432">
             <a:spAutoFit/>
           </a:bodyPr>
           <a:lstStyle/>
@@ -21665,7 +21849,7 @@
         </p:nvSpPr>
         <p:spPr>
           <a:xfrm>
-            <a:off x="2514600" y="1901952"/>
+            <a:off x="2433918" y="1901952"/>
             <a:ext cx="228600" cy="228600"/>
           </a:xfrm>
           <a:prstGeom prst="rect">
@@ -21674,7 +21858,7 @@
           <a:noFill/>
         </p:spPr>
         <p:txBody>
-          <a:bodyPr wrap="square" lIns="45720" rIns="45720" tIns="27432" bIns="27432">
+          <a:bodyPr wrap="square" lIns="45720" tIns="27432" rIns="45720" bIns="27432">
             <a:spAutoFit/>
           </a:bodyPr>
           <a:lstStyle/>
@@ -21688,6 +21872,7 @@
               </a:defRPr>
             </a:pPr>
             <a:r>
+              <a:rPr dirty="0"/>
               <a:t>→</a:t>
             </a:r>
           </a:p>
@@ -21735,6 +21920,7 @@
           <a:lstStyle/>
           <a:p>
             <a:pPr algn="ctr"/>
+            <a:endParaRPr/>
           </a:p>
         </p:txBody>
       </p:sp>
@@ -21778,6 +21964,7 @@
           <a:lstStyle/>
           <a:p>
             <a:pPr algn="ctr"/>
+            <a:endParaRPr/>
           </a:p>
         </p:txBody>
       </p:sp>
@@ -21798,7 +21985,7 @@
           <a:noFill/>
         </p:spPr>
         <p:txBody>
-          <a:bodyPr wrap="square" lIns="45720" rIns="45720" tIns="27432" bIns="27432">
+          <a:bodyPr wrap="square" lIns="45720" tIns="27432" rIns="45720" bIns="27432">
             <a:spAutoFit/>
           </a:bodyPr>
           <a:lstStyle/>
@@ -21834,7 +22021,7 @@
           <a:noFill/>
         </p:spPr>
         <p:txBody>
-          <a:bodyPr wrap="square" lIns="45720" rIns="45720" tIns="27432" bIns="27432">
+          <a:bodyPr wrap="square" lIns="45720" tIns="27432" rIns="45720" bIns="27432">
             <a:spAutoFit/>
           </a:bodyPr>
           <a:lstStyle/>
@@ -21861,7 +22048,7 @@
         </p:nvSpPr>
         <p:spPr>
           <a:xfrm>
-            <a:off x="4663440" y="1901952"/>
+            <a:off x="4609652" y="1901952"/>
             <a:ext cx="228600" cy="228600"/>
           </a:xfrm>
           <a:prstGeom prst="rect">
@@ -21870,7 +22057,7 @@
           <a:noFill/>
         </p:spPr>
         <p:txBody>
-          <a:bodyPr wrap="square" lIns="45720" rIns="45720" tIns="27432" bIns="27432">
+          <a:bodyPr wrap="square" lIns="45720" tIns="27432" rIns="45720" bIns="27432">
             <a:spAutoFit/>
           </a:bodyPr>
           <a:lstStyle/>
@@ -21931,6 +22118,7 @@
           <a:lstStyle/>
           <a:p>
             <a:pPr algn="ctr"/>
+            <a:endParaRPr/>
           </a:p>
         </p:txBody>
       </p:sp>
@@ -21974,6 +22162,7 @@
           <a:lstStyle/>
           <a:p>
             <a:pPr algn="ctr"/>
+            <a:endParaRPr/>
           </a:p>
         </p:txBody>
       </p:sp>
@@ -21994,7 +22183,7 @@
           <a:noFill/>
         </p:spPr>
         <p:txBody>
-          <a:bodyPr wrap="square" lIns="45720" rIns="45720" tIns="27432" bIns="27432">
+          <a:bodyPr wrap="square" lIns="45720" tIns="27432" rIns="45720" bIns="27432">
             <a:spAutoFit/>
           </a:bodyPr>
           <a:lstStyle/>
@@ -22030,7 +22219,7 @@
           <a:noFill/>
         </p:spPr>
         <p:txBody>
-          <a:bodyPr wrap="square" lIns="45720" rIns="45720" tIns="27432" bIns="27432">
+          <a:bodyPr wrap="square" lIns="45720" tIns="27432" rIns="45720" bIns="27432">
             <a:spAutoFit/>
           </a:bodyPr>
           <a:lstStyle/>
@@ -22057,7 +22246,7 @@
         </p:nvSpPr>
         <p:spPr>
           <a:xfrm>
-            <a:off x="6812280" y="1901952"/>
+            <a:off x="6745045" y="1901952"/>
             <a:ext cx="228600" cy="228600"/>
           </a:xfrm>
           <a:prstGeom prst="rect">
@@ -22066,7 +22255,7 @@
           <a:noFill/>
         </p:spPr>
         <p:txBody>
-          <a:bodyPr wrap="square" lIns="45720" rIns="45720" tIns="27432" bIns="27432">
+          <a:bodyPr wrap="square" lIns="45720" tIns="27432" rIns="45720" bIns="27432">
             <a:spAutoFit/>
           </a:bodyPr>
           <a:lstStyle/>
@@ -22080,6 +22269,7 @@
               </a:defRPr>
             </a:pPr>
             <a:r>
+              <a:rPr dirty="0"/>
               <a:t>→</a:t>
             </a:r>
           </a:p>
@@ -22127,6 +22317,7 @@
           <a:lstStyle/>
           <a:p>
             <a:pPr algn="ctr"/>
+            <a:endParaRPr/>
           </a:p>
         </p:txBody>
       </p:sp>
@@ -22170,6 +22361,7 @@
           <a:lstStyle/>
           <a:p>
             <a:pPr algn="ctr"/>
+            <a:endParaRPr/>
           </a:p>
         </p:txBody>
       </p:sp>
@@ -22190,7 +22382,7 @@
           <a:noFill/>
         </p:spPr>
         <p:txBody>
-          <a:bodyPr wrap="square" lIns="45720" rIns="45720" tIns="27432" bIns="27432">
+          <a:bodyPr wrap="square" lIns="45720" tIns="27432" rIns="45720" bIns="27432">
             <a:spAutoFit/>
           </a:bodyPr>
           <a:lstStyle/>
@@ -22226,7 +22418,7 @@
           <a:noFill/>
         </p:spPr>
         <p:txBody>
-          <a:bodyPr wrap="square" lIns="45720" rIns="45720" tIns="27432" bIns="27432">
+          <a:bodyPr wrap="square" lIns="45720" tIns="27432" rIns="45720" bIns="27432">
             <a:spAutoFit/>
           </a:bodyPr>
           <a:lstStyle/>
@@ -22253,7 +22445,7 @@
         </p:nvSpPr>
         <p:spPr>
           <a:xfrm>
-            <a:off x="8961120" y="1901952"/>
+            <a:off x="8893885" y="1901952"/>
             <a:ext cx="228600" cy="228600"/>
           </a:xfrm>
           <a:prstGeom prst="rect">
@@ -22262,7 +22454,7 @@
           <a:noFill/>
         </p:spPr>
         <p:txBody>
-          <a:bodyPr wrap="square" lIns="45720" rIns="45720" tIns="27432" bIns="27432">
+          <a:bodyPr wrap="square" lIns="45720" tIns="27432" rIns="45720" bIns="27432">
             <a:spAutoFit/>
           </a:bodyPr>
           <a:lstStyle/>
@@ -22323,6 +22515,7 @@
           <a:lstStyle/>
           <a:p>
             <a:pPr algn="ctr"/>
+            <a:endParaRPr/>
           </a:p>
         </p:txBody>
       </p:sp>
@@ -22366,6 +22559,7 @@
           <a:lstStyle/>
           <a:p>
             <a:pPr algn="ctr"/>
+            <a:endParaRPr/>
           </a:p>
         </p:txBody>
       </p:sp>
@@ -22386,7 +22580,7 @@
           <a:noFill/>
         </p:spPr>
         <p:txBody>
-          <a:bodyPr wrap="square" lIns="45720" rIns="45720" tIns="27432" bIns="27432">
+          <a:bodyPr wrap="square" lIns="45720" tIns="27432" rIns="45720" bIns="27432">
             <a:spAutoFit/>
           </a:bodyPr>
           <a:lstStyle/>
@@ -22422,7 +22616,7 @@
           <a:noFill/>
         </p:spPr>
         <p:txBody>
-          <a:bodyPr wrap="square" lIns="45720" rIns="45720" tIns="27432" bIns="27432">
+          <a:bodyPr wrap="square" lIns="45720" tIns="27432" rIns="45720" bIns="27432">
             <a:spAutoFit/>
           </a:bodyPr>
           <a:lstStyle/>
@@ -22436,6 +22630,7 @@
               </a:defRPr>
             </a:pPr>
             <a:r>
+              <a:rPr dirty="0"/>
               <a:t>enrich master + hide duplicates</a:t>
             </a:r>
           </a:p>
@@ -22483,6 +22678,7 @@
           <a:lstStyle/>
           <a:p>
             <a:pPr algn="ctr"/>
+            <a:endParaRPr/>
           </a:p>
         </p:txBody>
       </p:sp>
@@ -22526,6 +22722,7 @@
           <a:lstStyle/>
           <a:p>
             <a:pPr algn="ctr"/>
+            <a:endParaRPr/>
           </a:p>
         </p:txBody>
       </p:sp>
@@ -22546,7 +22743,7 @@
           <a:noFill/>
         </p:spPr>
         <p:txBody>
-          <a:bodyPr wrap="square" lIns="45720" rIns="45720" tIns="27432" bIns="27432">
+          <a:bodyPr wrap="square" lIns="45720" tIns="27432" rIns="45720" bIns="27432">
             <a:spAutoFit/>
           </a:bodyPr>
           <a:lstStyle/>
@@ -22582,7 +22779,7 @@
           <a:noFill/>
         </p:spPr>
         <p:txBody>
-          <a:bodyPr wrap="square" lIns="45720" rIns="45720" tIns="27432" bIns="27432">
+          <a:bodyPr wrap="square" lIns="45720" tIns="27432" rIns="45720" bIns="27432">
             <a:spAutoFit/>
           </a:bodyPr>
           <a:lstStyle/>
@@ -22643,6 +22840,7 @@
           <a:lstStyle/>
           <a:p>
             <a:pPr algn="ctr"/>
+            <a:endParaRPr/>
           </a:p>
         </p:txBody>
       </p:sp>
@@ -22686,6 +22884,7 @@
           <a:lstStyle/>
           <a:p>
             <a:pPr algn="ctr"/>
+            <a:endParaRPr/>
           </a:p>
         </p:txBody>
       </p:sp>
@@ -22706,7 +22905,7 @@
           <a:noFill/>
         </p:spPr>
         <p:txBody>
-          <a:bodyPr wrap="square" lIns="45720" rIns="45720" tIns="27432" bIns="27432">
+          <a:bodyPr wrap="square" lIns="45720" tIns="27432" rIns="45720" bIns="27432">
             <a:spAutoFit/>
           </a:bodyPr>
           <a:lstStyle/>
@@ -22742,7 +22941,7 @@
           <a:noFill/>
         </p:spPr>
         <p:txBody>
-          <a:bodyPr wrap="square" lIns="45720" rIns="45720" tIns="27432" bIns="27432">
+          <a:bodyPr wrap="square" lIns="45720" tIns="27432" rIns="45720" bIns="27432">
             <a:spAutoFit/>
           </a:bodyPr>
           <a:lstStyle/>
@@ -22803,6 +23002,7 @@
           <a:lstStyle/>
           <a:p>
             <a:pPr algn="ctr"/>
+            <a:endParaRPr/>
           </a:p>
         </p:txBody>
       </p:sp>
@@ -22846,6 +23046,7 @@
           <a:lstStyle/>
           <a:p>
             <a:pPr algn="ctr"/>
+            <a:endParaRPr/>
           </a:p>
         </p:txBody>
       </p:sp>
@@ -22866,7 +23067,7 @@
           <a:noFill/>
         </p:spPr>
         <p:txBody>
-          <a:bodyPr wrap="square" lIns="45720" rIns="45720" tIns="27432" bIns="27432">
+          <a:bodyPr wrap="square" lIns="45720" tIns="27432" rIns="45720" bIns="27432">
             <a:spAutoFit/>
           </a:bodyPr>
           <a:lstStyle/>
@@ -22902,7 +23103,7 @@
           <a:noFill/>
         </p:spPr>
         <p:txBody>
-          <a:bodyPr wrap="square" lIns="45720" rIns="45720" tIns="27432" bIns="27432">
+          <a:bodyPr wrap="square" lIns="45720" tIns="27432" rIns="45720" bIns="27432">
             <a:spAutoFit/>
           </a:bodyPr>
           <a:lstStyle/>
@@ -23751,15 +23952,6 @@
 </file>
 
 <file path=customXml/item1.xml><?xml version="1.0" encoding="utf-8"?>
-<?mso-contentType ?>
-<FormTemplates xmlns="http://schemas.microsoft.com/sharepoint/v3/contenttype/forms">
-  <Display>DocumentLibraryForm</Display>
-  <Edit>DocumentLibraryForm</Edit>
-  <New>DocumentLibraryForm</New>
-</FormTemplates>
-</file>
-
-<file path=customXml/item2.xml><?xml version="1.0" encoding="utf-8"?>
 <ct:contentTypeSchema xmlns:ct="http://schemas.microsoft.com/office/2006/metadata/contentType" xmlns:ma="http://schemas.microsoft.com/office/2006/metadata/properties/metaAttributes" ct:_="" ma:_="" ma:contentTypeName="Document" ma:contentTypeID="0x0101002F38A681A198CE49B506127E145C338B" ma:contentTypeVersion="18" ma:contentTypeDescription="Create a new document." ma:contentTypeScope="" ma:versionID="6890dc05a4cd7a958d98b3dfa249acfb">
   <xsd:schema xmlns:xsd="http://www.w3.org/2001/XMLSchema" xmlns:xs="http://www.w3.org/2001/XMLSchema" xmlns:p="http://schemas.microsoft.com/office/2006/metadata/properties" xmlns:ns1="http://schemas.microsoft.com/sharepoint/v3" xmlns:ns2="22413639-5697-482c-b7bb-e04906986a73" xmlns:ns3="a924370c-fc62-407f-b90c-d93bf7e90cd9" targetNamespace="http://schemas.microsoft.com/office/2006/metadata/properties" ma:root="true" ma:fieldsID="0eeee2e4eb8341728e11ab3caba7f16e" ns1:_="" ns2:_="" ns3:_="">
     <xsd:import namespace="http://schemas.microsoft.com/sharepoint/v3"/>
@@ -24017,6 +24209,15 @@
 </ct:contentTypeSchema>
 </file>
 
+<file path=customXml/item2.xml><?xml version="1.0" encoding="utf-8"?>
+<?mso-contentType ?>
+<FormTemplates xmlns="http://schemas.microsoft.com/sharepoint/v3/contenttype/forms">
+  <Display>DocumentLibraryForm</Display>
+  <Edit>DocumentLibraryForm</Edit>
+  <New>DocumentLibraryForm</New>
+</FormTemplates>
+</file>
+
 <file path=customXml/item3.xml><?xml version="1.0" encoding="utf-8"?>
 <p:properties xmlns:p="http://schemas.microsoft.com/office/2006/metadata/properties" xmlns:xsi="http://www.w3.org/2001/XMLSchema-instance" xmlns:pc="http://schemas.microsoft.com/office/infopath/2007/PartnerControls">
   <documentManagement>
@@ -24039,14 +24240,6 @@
 </file>
 
 <file path=customXml/itemProps1.xml><?xml version="1.0" encoding="utf-8"?>
-<ds:datastoreItem xmlns:ds="http://schemas.openxmlformats.org/officeDocument/2006/customXml" ds:itemID="{C30BB809-624E-4D49-97EF-1B3AC7456074}">
-  <ds:schemaRefs>
-    <ds:schemaRef ds:uri="http://schemas.microsoft.com/sharepoint/v3/contenttype/forms"/>
-  </ds:schemaRefs>
-</ds:datastoreItem>
-</file>
-
-<file path=customXml/itemProps2.xml><?xml version="1.0" encoding="utf-8"?>
 <ds:datastoreItem xmlns:ds="http://schemas.openxmlformats.org/officeDocument/2006/customXml" ds:itemID="{71C33FE5-90AD-40BF-8522-D6888562052B}">
   <ds:schemaRefs>
     <ds:schemaRef ds:uri="22413639-5697-482c-b7bb-e04906986a73"/>
@@ -24062,6 +24255,14 @@
     <ds:schemaRef ds:uri="http://schemas.microsoft.com/sharepoint/v3"/>
     <ds:schemaRef ds:uri="http://schemas.openxmlformats.org/package/2006/metadata/core-properties"/>
     <ds:schemaRef ds:uri="http://www.w3.org/2001/XMLSchema"/>
+  </ds:schemaRefs>
+</ds:datastoreItem>
+</file>
+
+<file path=customXml/itemProps2.xml><?xml version="1.0" encoding="utf-8"?>
+<ds:datastoreItem xmlns:ds="http://schemas.openxmlformats.org/officeDocument/2006/customXml" ds:itemID="{C30BB809-624E-4D49-97EF-1B3AC7456074}">
+  <ds:schemaRefs>
+    <ds:schemaRef ds:uri="http://schemas.microsoft.com/sharepoint/v3/contenttype/forms"/>
   </ds:schemaRefs>
 </ds:datastoreItem>
 </file>

</xml_diff>